<commit_message>
slides: english boris-style deck (keybindings, models, agents, style-guide)
</commit_message>
<xml_diff>
--- a/claude-code-seminar.pptx
+++ b/claude-code-seminar.pptx
@@ -28,9 +28,11 @@
     <p:sldId id="276" r:id="rId22"/>
     <p:sldId id="277" r:id="rId23"/>
     <p:sldId id="278" r:id="rId24"/>
+    <p:sldId id="279" r:id="rId25"/>
+    <p:sldId id="280" r:id="rId26"/>
   </p:sldIdLst>
   <p:notesMasterIdLst>
-    <p:notesMasterId r:id="rId25"/>
+    <p:notesMasterId r:id="rId27"/>
   </p:notesMasterIdLst>
   <p:sldSz cx="12192000" cy="6858000"/>
   <p:notesSz cx="6858000" cy="12192000"/>
@@ -1580,7 +1582,7 @@
           <a:p>
             <a:r>
               <a:rPr lang="en-US" dirty="0"/>
-              <a:t/>
+              <a:t>No special syntax needed — plain language. /agents opens the manager to create reusable specialized agents with their own prompt and tools.</a:t>
             </a:r>
             <a:endParaRPr lang="en-US" dirty="0"/>
           </a:p>
@@ -1756,7 +1758,7 @@
           <a:p>
             <a:r>
               <a:rPr lang="en-US" dirty="0"/>
-              <a:t/>
+              <a:t>Run this once per project. The style guide travels to Claude Design so mockups come back already on-brand, then back into Claude Code to implement.</a:t>
             </a:r>
             <a:endParaRPr lang="en-US" dirty="0"/>
           </a:p>
@@ -1868,6 +1870,182 @@
             <a:fld id="{F7021451-1387-4CA6-816F-3879F97B5CBC}" type="slidenum">
               <a:rPr lang="en-US"/>
               <a:t>23</a:t>
+            </a:fld>
+            <a:endParaRPr lang="en-US"/>
+          </a:p>
+        </p:txBody>
+      </p:sp>
+    </p:spTree>
+    <p:extLst>
+      <p:ext uri="{BB962C8B-B14F-4D97-AF65-F5344CB8AC3E}">
+        <p14:creationId xmlns:p14="http://schemas.microsoft.com/office/powerpoint/2010/main" val="1024086991"/>
+      </p:ext>
+    </p:extLst>
+  </p:cSld>
+  <p:clrMapOvr>
+    <a:masterClrMapping/>
+  </p:clrMapOvr>
+</p:notes>
+</file>
+
+<file path=ppt/notesSlides/notesSlide24.xml><?xml version="1.0" encoding="utf-8"?>
+<p:notes xmlns:a="http://schemas.openxmlformats.org/drawingml/2006/main" xmlns:r="http://schemas.openxmlformats.org/officeDocument/2006/relationships" xmlns:p="http://schemas.openxmlformats.org/presentationml/2006/main">
+  <p:cSld>
+    <p:spTree>
+      <p:nvGrpSpPr>
+        <p:cNvPr id="1" name=""/>
+        <p:cNvGrpSpPr/>
+        <p:nvPr/>
+      </p:nvGrpSpPr>
+      <p:grpSpPr>
+        <a:xfrm>
+          <a:off x="0" y="0"/>
+          <a:ext cx="0" cy="0"/>
+          <a:chOff x="0" y="0"/>
+          <a:chExt cx="0" cy="0"/>
+        </a:xfrm>
+      </p:grpSpPr>
+      <p:sp>
+        <p:nvSpPr>
+          <p:cNvPr id="2" name="Slide Image Placeholder 1"/>
+          <p:cNvSpPr>
+            <a:spLocks noGrp="1" noRot="1" noChangeAspect="1"/>
+          </p:cNvSpPr>
+          <p:nvPr>
+            <p:ph type="sldImg"/>
+          </p:nvPr>
+        </p:nvSpPr>
+        <p:spPr/>
+      </p:sp>
+      <p:sp>
+        <p:nvSpPr>
+          <p:cNvPr id="3" name="Notes Placeholder 2"/>
+          <p:cNvSpPr>
+            <a:spLocks noGrp="1"/>
+          </p:cNvSpPr>
+          <p:nvPr>
+            <p:ph type="body" idx="1"/>
+          </p:nvPr>
+        </p:nvSpPr>
+        <p:spPr/>
+        <p:txBody>
+          <a:bodyPr/>
+          <a:lstStyle/>
+          <a:p>
+            <a:r>
+              <a:rPr lang="en-US" dirty="0"/>
+              <a:t/>
+            </a:r>
+            <a:endParaRPr lang="en-US" dirty="0"/>
+          </a:p>
+        </p:txBody>
+      </p:sp>
+      <p:sp>
+        <p:nvSpPr>
+          <p:cNvPr id="4" name="Slide Number Placeholder 3"/>
+          <p:cNvSpPr>
+            <a:spLocks noGrp="1"/>
+          </p:cNvSpPr>
+          <p:nvPr>
+            <p:ph type="sldNum" sz="quarter" idx="10"/>
+          </p:nvPr>
+        </p:nvSpPr>
+        <p:spPr/>
+        <p:txBody>
+          <a:bodyPr/>
+          <a:lstStyle/>
+          <a:p>
+            <a:fld id="{F7021451-1387-4CA6-816F-3879F97B5CBC}" type="slidenum">
+              <a:rPr lang="en-US"/>
+              <a:t>24</a:t>
+            </a:fld>
+            <a:endParaRPr lang="en-US"/>
+          </a:p>
+        </p:txBody>
+      </p:sp>
+    </p:spTree>
+    <p:extLst>
+      <p:ext uri="{BB962C8B-B14F-4D97-AF65-F5344CB8AC3E}">
+        <p14:creationId xmlns:p14="http://schemas.microsoft.com/office/powerpoint/2010/main" val="1024086991"/>
+      </p:ext>
+    </p:extLst>
+  </p:cSld>
+  <p:clrMapOvr>
+    <a:masterClrMapping/>
+  </p:clrMapOvr>
+</p:notes>
+</file>
+
+<file path=ppt/notesSlides/notesSlide25.xml><?xml version="1.0" encoding="utf-8"?>
+<p:notes xmlns:a="http://schemas.openxmlformats.org/drawingml/2006/main" xmlns:r="http://schemas.openxmlformats.org/officeDocument/2006/relationships" xmlns:p="http://schemas.openxmlformats.org/presentationml/2006/main">
+  <p:cSld>
+    <p:spTree>
+      <p:nvGrpSpPr>
+        <p:cNvPr id="1" name=""/>
+        <p:cNvGrpSpPr/>
+        <p:nvPr/>
+      </p:nvGrpSpPr>
+      <p:grpSpPr>
+        <a:xfrm>
+          <a:off x="0" y="0"/>
+          <a:ext cx="0" cy="0"/>
+          <a:chOff x="0" y="0"/>
+          <a:chExt cx="0" cy="0"/>
+        </a:xfrm>
+      </p:grpSpPr>
+      <p:sp>
+        <p:nvSpPr>
+          <p:cNvPr id="2" name="Slide Image Placeholder 1"/>
+          <p:cNvSpPr>
+            <a:spLocks noGrp="1" noRot="1" noChangeAspect="1"/>
+          </p:cNvSpPr>
+          <p:nvPr>
+            <p:ph type="sldImg"/>
+          </p:nvPr>
+        </p:nvSpPr>
+        <p:spPr/>
+      </p:sp>
+      <p:sp>
+        <p:nvSpPr>
+          <p:cNvPr id="3" name="Notes Placeholder 2"/>
+          <p:cNvSpPr>
+            <a:spLocks noGrp="1"/>
+          </p:cNvSpPr>
+          <p:nvPr>
+            <p:ph type="body" idx="1"/>
+          </p:nvPr>
+        </p:nvSpPr>
+        <p:spPr/>
+        <p:txBody>
+          <a:bodyPr/>
+          <a:lstStyle/>
+          <a:p>
+            <a:r>
+              <a:rPr lang="en-US" dirty="0"/>
+              <a:t/>
+            </a:r>
+            <a:endParaRPr lang="en-US" dirty="0"/>
+          </a:p>
+        </p:txBody>
+      </p:sp>
+      <p:sp>
+        <p:nvSpPr>
+          <p:cNvPr id="4" name="Slide Number Placeholder 3"/>
+          <p:cNvSpPr>
+            <a:spLocks noGrp="1"/>
+          </p:cNvSpPr>
+          <p:nvPr>
+            <p:ph type="sldNum" sz="quarter" idx="10"/>
+          </p:nvPr>
+        </p:nvSpPr>
+        <p:spPr/>
+        <p:txBody>
+          <a:bodyPr/>
+          <a:lstStyle/>
+          <a:p>
+            <a:fld id="{F7021451-1387-4CA6-816F-3879F97B5CBC}" type="slidenum">
+              <a:rPr lang="en-US"/>
+              <a:t>25</a:t>
             </a:fld>
             <a:endParaRPr lang="en-US"/>
           </a:p>
@@ -6450,7 +6628,7 @@
               <a:buNone/>
             </a:pPr>
             <a:r>
-              <a:rPr lang="en-US" sz="3000" b="1" dirty="0">
+              <a:rPr lang="en-US" sz="2800" b="1" dirty="0">
                 <a:solidFill>
                   <a:srgbClr val="F5F1EA"/>
                 </a:solidFill>
@@ -6458,9 +6636,9 @@
                 <a:ea typeface="Courier New" pitchFamily="34" charset="-122"/>
                 <a:cs typeface="Courier New" pitchFamily="34" charset="-120"/>
               </a:rPr>
-              <a:t>claude design → claude code</a:t>
-            </a:r>
-            <a:endParaRPr lang="en-US" sz="3000" dirty="0"/>
+              <a:t>how to launch them: just ask</a:t>
+            </a:r>
+            <a:endParaRPr lang="en-US" sz="2800" dirty="0"/>
           </a:p>
         </p:txBody>
       </p:sp>
@@ -6472,8 +6650,8 @@
         </p:nvSpPr>
         <p:spPr>
           <a:xfrm>
-            <a:off x="822960" y="2103120"/>
-            <a:ext cx="10543032" cy="4114800"/>
+            <a:off x="822960" y="1828800"/>
+            <a:ext cx="10543032" cy="4389120"/>
           </a:xfrm>
           <a:prstGeom prst="rect">
             <a:avLst/>
@@ -6495,7 +6673,88 @@
               <a:buNone/>
             </a:pPr>
             <a:r>
-              <a:rPr lang="en-US" sz="1900" dirty="0">
+              <a:rPr lang="en-US" sz="1700" dirty="0">
+                <a:solidFill>
+                  <a:srgbClr val="D97757"/>
+                </a:solidFill>
+                <a:latin typeface="Courier New" pitchFamily="34" charset="0"/>
+                <a:ea typeface="Courier New" pitchFamily="34" charset="-122"/>
+                <a:cs typeface="Courier New" pitchFamily="34" charset="-120"/>
+              </a:rPr>
+              <a:t>"use a subagent to find every place we validate emails"</a:t>
+            </a:r>
+            <a:endParaRPr lang="en-US" sz="1700" dirty="0"/>
+          </a:p>
+          <a:p>
+            <a:pPr algn="l" indent="0" marL="0">
+              <a:lnSpc>
+                <a:spcPts val="3800"/>
+              </a:lnSpc>
+              <a:spcAft>
+                <a:spcPts val="1000"/>
+              </a:spcAft>
+              <a:buNone/>
+            </a:pPr>
+            <a:r>
+              <a:rPr lang="en-US" sz="1700" dirty="0">
+                <a:solidFill>
+                  <a:srgbClr val="D97757"/>
+                </a:solidFill>
+                <a:latin typeface="Courier New" pitchFamily="34" charset="0"/>
+                <a:ea typeface="Courier New" pitchFamily="34" charset="-122"/>
+                <a:cs typeface="Courier New" pitchFamily="34" charset="-120"/>
+              </a:rPr>
+              <a:t>"launch 3 agents in parallel, one per module"</a:t>
+            </a:r>
+            <a:endParaRPr lang="en-US" sz="1700" dirty="0"/>
+          </a:p>
+          <a:p>
+            <a:pPr algn="l" indent="0" marL="0">
+              <a:lnSpc>
+                <a:spcPts val="3800"/>
+              </a:lnSpc>
+              <a:spcAft>
+                <a:spcPts val="1000"/>
+              </a:spcAft>
+              <a:buNone/>
+            </a:pPr>
+            <a:r>
+              <a:rPr lang="en-US" sz="1700" dirty="0">
+                <a:solidFill>
+                  <a:srgbClr val="D97757"/>
+                </a:solidFill>
+                <a:latin typeface="Courier New" pitchFamily="34" charset="0"/>
+                <a:ea typeface="Courier New" pitchFamily="34" charset="-122"/>
+                <a:cs typeface="Courier New" pitchFamily="34" charset="-120"/>
+              </a:rPr>
+              <a:t>"have an agent review this diff before we commit"</a:t>
+            </a:r>
+            <a:endParaRPr lang="en-US" sz="1700" dirty="0"/>
+          </a:p>
+          <a:p>
+            <a:pPr algn="l" indent="0" marL="0">
+              <a:lnSpc>
+                <a:spcPts val="3800"/>
+              </a:lnSpc>
+              <a:spcAft>
+                <a:spcPts val="1000"/>
+              </a:spcAft>
+              <a:buNone/>
+            </a:pPr>
+            <a:endParaRPr lang="en-US" sz="1700" dirty="0"/>
+          </a:p>
+          <a:p>
+            <a:pPr algn="l" indent="0" marL="0">
+              <a:lnSpc>
+                <a:spcPts val="3800"/>
+              </a:lnSpc>
+              <a:spcAft>
+                <a:spcPts val="1000"/>
+              </a:spcAft>
+              <a:buNone/>
+            </a:pPr>
+            <a:r>
+              <a:rPr lang="en-US" sz="1700" dirty="0">
                 <a:solidFill>
                   <a:srgbClr val="F5F1EA"/>
                 </a:solidFill>
@@ -6503,11 +6762,8 @@
                 <a:ea typeface="Courier New" pitchFamily="34" charset="-122"/>
                 <a:cs typeface="Courier New" pitchFamily="34" charset="-120"/>
               </a:rPr>
-              <a:t>design the ux/ui in claude design (web)</a:t>
-            </a:r>
-            <a:endParaRPr lang="en-US" sz="1900" dirty="0"/>
-          </a:p>
-          <a:p>
+              <a:t>/agents</a:t>
+            </a:r>
             <a:pPr algn="l" indent="0" marL="0">
               <a:lnSpc>
                 <a:spcPts val="3800"/>
@@ -6518,17 +6774,17 @@
               <a:buNone/>
             </a:pPr>
             <a:r>
-              <a:rPr lang="en-US" sz="1900" dirty="0">
-                <a:solidFill>
-                  <a:srgbClr val="F5F1EA"/>
-                </a:solidFill>
-                <a:latin typeface="Courier New" pitchFamily="34" charset="0"/>
-                <a:ea typeface="Courier New" pitchFamily="34" charset="-122"/>
-                <a:cs typeface="Courier New" pitchFamily="34" charset="-120"/>
-              </a:rPr>
-              <a:t>bring it back into claude code</a:t>
-            </a:r>
-            <a:endParaRPr lang="en-US" sz="1900" dirty="0"/>
+              <a:rPr lang="en-US" sz="1700" dirty="0">
+                <a:solidFill>
+                  <a:srgbClr val="8C8578"/>
+                </a:solidFill>
+                <a:latin typeface="Courier New" pitchFamily="34" charset="0"/>
+                <a:ea typeface="Courier New" pitchFamily="34" charset="-122"/>
+                <a:cs typeface="Courier New" pitchFamily="34" charset="-120"/>
+              </a:rPr>
+              <a:t>   define custom specialists (reviewer, tester…)</a:t>
+            </a:r>
+            <a:endParaRPr lang="en-US" sz="1700" dirty="0"/>
           </a:p>
           <a:p>
             <a:pPr algn="l" indent="0" marL="0">
@@ -6541,52 +6797,17 @@
               <a:buNone/>
             </a:pPr>
             <a:r>
-              <a:rPr lang="en-US" sz="1900" dirty="0">
-                <a:solidFill>
-                  <a:srgbClr val="F5F1EA"/>
-                </a:solidFill>
-                <a:latin typeface="Courier New" pitchFamily="34" charset="0"/>
-                <a:ea typeface="Courier New" pitchFamily="34" charset="-122"/>
-                <a:cs typeface="Courier New" pitchFamily="34" charset="-120"/>
-              </a:rPr>
-              <a:t>implement it directly on the project</a:t>
-            </a:r>
-            <a:endParaRPr lang="en-US" sz="1900" dirty="0"/>
-          </a:p>
-          <a:p>
-            <a:pPr algn="l" indent="0" marL="0">
-              <a:lnSpc>
-                <a:spcPts val="3800"/>
-              </a:lnSpc>
-              <a:spcAft>
-                <a:spcPts val="1000"/>
-              </a:spcAft>
-              <a:buNone/>
-            </a:pPr>
-            <a:endParaRPr lang="en-US" sz="1900" dirty="0"/>
-          </a:p>
-          <a:p>
-            <a:pPr algn="l" indent="0" marL="0">
-              <a:lnSpc>
-                <a:spcPts val="3800"/>
-              </a:lnSpc>
-              <a:spcAft>
-                <a:spcPts val="1000"/>
-              </a:spcAft>
-              <a:buNone/>
-            </a:pPr>
-            <a:r>
-              <a:rPr lang="en-US" sz="1900" dirty="0">
-                <a:solidFill>
-                  <a:srgbClr val="D97757"/>
-                </a:solidFill>
-                <a:latin typeface="Courier New" pitchFamily="34" charset="0"/>
-                <a:ea typeface="Courier New" pitchFamily="34" charset="-122"/>
-                <a:cs typeface="Courier New" pitchFamily="34" charset="-120"/>
-              </a:rPr>
-              <a:t>design → code, without rewriting markup by hand</a:t>
-            </a:r>
-            <a:endParaRPr lang="en-US" sz="1900" dirty="0"/>
+              <a:rPr lang="en-US" sz="1700" dirty="0">
+                <a:solidFill>
+                  <a:srgbClr val="8C8578"/>
+                </a:solidFill>
+                <a:latin typeface="Courier New" pitchFamily="34" charset="0"/>
+                <a:ea typeface="Courier New" pitchFamily="34" charset="-122"/>
+                <a:cs typeface="Courier New" pitchFamily="34" charset="-120"/>
+              </a:rPr>
+              <a:t>          stored in .claude/agents — shared with the team</a:t>
+            </a:r>
+            <a:endParaRPr lang="en-US" sz="1700" dirty="0"/>
           </a:p>
         </p:txBody>
       </p:sp>
@@ -6687,7 +6908,7 @@
                 <a:ea typeface="Courier New" pitchFamily="34" charset="-122"/>
                 <a:cs typeface="Courier New" pitchFamily="34" charset="-120"/>
               </a:rPr>
-              <a:t>learn more</a:t>
+              <a:t>claude design → claude code</a:t>
             </a:r>
             <a:endParaRPr lang="en-US" sz="3000" dirty="0"/>
           </a:p>
@@ -6701,8 +6922,8 @@
         </p:nvSpPr>
         <p:spPr>
           <a:xfrm>
-            <a:off x="822960" y="1828800"/>
-            <a:ext cx="10543032" cy="4389120"/>
+            <a:off x="822960" y="2103120"/>
+            <a:ext cx="10543032" cy="4114800"/>
           </a:xfrm>
           <a:prstGeom prst="rect">
             <a:avLst/>
@@ -6716,15 +6937,96 @@
           <a:p>
             <a:pPr algn="l" indent="0" marL="0">
               <a:lnSpc>
-                <a:spcPts val="3600"/>
-              </a:lnSpc>
-              <a:spcAft>
-                <a:spcPts val="1000"/>
-              </a:spcAft>
-              <a:buNone/>
-            </a:pPr>
-            <a:r>
-              <a:rPr lang="en-US" sz="1800" dirty="0">
+                <a:spcPts val="3800"/>
+              </a:lnSpc>
+              <a:spcAft>
+                <a:spcPts val="1000"/>
+              </a:spcAft>
+              <a:buNone/>
+            </a:pPr>
+            <a:r>
+              <a:rPr lang="en-US" sz="1900" dirty="0">
+                <a:solidFill>
+                  <a:srgbClr val="F5F1EA"/>
+                </a:solidFill>
+                <a:latin typeface="Courier New" pitchFamily="34" charset="0"/>
+                <a:ea typeface="Courier New" pitchFamily="34" charset="-122"/>
+                <a:cs typeface="Courier New" pitchFamily="34" charset="-120"/>
+              </a:rPr>
+              <a:t>design the ux/ui in claude design (web)</a:t>
+            </a:r>
+            <a:endParaRPr lang="en-US" sz="1900" dirty="0"/>
+          </a:p>
+          <a:p>
+            <a:pPr algn="l" indent="0" marL="0">
+              <a:lnSpc>
+                <a:spcPts val="3800"/>
+              </a:lnSpc>
+              <a:spcAft>
+                <a:spcPts val="1000"/>
+              </a:spcAft>
+              <a:buNone/>
+            </a:pPr>
+            <a:r>
+              <a:rPr lang="en-US" sz="1900" dirty="0">
+                <a:solidFill>
+                  <a:srgbClr val="F5F1EA"/>
+                </a:solidFill>
+                <a:latin typeface="Courier New" pitchFamily="34" charset="0"/>
+                <a:ea typeface="Courier New" pitchFamily="34" charset="-122"/>
+                <a:cs typeface="Courier New" pitchFamily="34" charset="-120"/>
+              </a:rPr>
+              <a:t>bring it back into claude code</a:t>
+            </a:r>
+            <a:endParaRPr lang="en-US" sz="1900" dirty="0"/>
+          </a:p>
+          <a:p>
+            <a:pPr algn="l" indent="0" marL="0">
+              <a:lnSpc>
+                <a:spcPts val="3800"/>
+              </a:lnSpc>
+              <a:spcAft>
+                <a:spcPts val="1000"/>
+              </a:spcAft>
+              <a:buNone/>
+            </a:pPr>
+            <a:r>
+              <a:rPr lang="en-US" sz="1900" dirty="0">
+                <a:solidFill>
+                  <a:srgbClr val="F5F1EA"/>
+                </a:solidFill>
+                <a:latin typeface="Courier New" pitchFamily="34" charset="0"/>
+                <a:ea typeface="Courier New" pitchFamily="34" charset="-122"/>
+                <a:cs typeface="Courier New" pitchFamily="34" charset="-120"/>
+              </a:rPr>
+              <a:t>implement it directly on the project</a:t>
+            </a:r>
+            <a:endParaRPr lang="en-US" sz="1900" dirty="0"/>
+          </a:p>
+          <a:p>
+            <a:pPr algn="l" indent="0" marL="0">
+              <a:lnSpc>
+                <a:spcPts val="3800"/>
+              </a:lnSpc>
+              <a:spcAft>
+                <a:spcPts val="1000"/>
+              </a:spcAft>
+              <a:buNone/>
+            </a:pPr>
+            <a:endParaRPr lang="en-US" sz="1900" dirty="0"/>
+          </a:p>
+          <a:p>
+            <a:pPr algn="l" indent="0" marL="0">
+              <a:lnSpc>
+                <a:spcPts val="3800"/>
+              </a:lnSpc>
+              <a:spcAft>
+                <a:spcPts val="1000"/>
+              </a:spcAft>
+              <a:buNone/>
+            </a:pPr>
+            <a:r>
+              <a:rPr lang="en-US" sz="1900" dirty="0">
                 <a:solidFill>
                   <a:srgbClr val="D97757"/>
                 </a:solidFill>
@@ -6732,213 +7034,9 @@
                 <a:ea typeface="Courier New" pitchFamily="34" charset="-122"/>
                 <a:cs typeface="Courier New" pitchFamily="34" charset="-120"/>
               </a:rPr>
-              <a:t>anthropic.skilljar.com</a:t>
-            </a:r>
-            <a:pPr algn="l" indent="0" marL="0">
-              <a:lnSpc>
-                <a:spcPts val="3600"/>
-              </a:lnSpc>
-              <a:spcAft>
-                <a:spcPts val="1000"/>
-              </a:spcAft>
-              <a:buNone/>
-            </a:pPr>
-            <a:r>
-              <a:rPr lang="en-US" sz="1800" dirty="0">
-                <a:solidFill>
-                  <a:srgbClr val="8C8578"/>
-                </a:solidFill>
-                <a:latin typeface="Courier New" pitchFamily="34" charset="0"/>
-                <a:ea typeface="Courier New" pitchFamily="34" charset="-122"/>
-                <a:cs typeface="Courier New" pitchFamily="34" charset="-120"/>
-              </a:rPr>
-              <a:t>   free official courses, certificate</a:t>
-            </a:r>
-            <a:endParaRPr lang="en-US" sz="1800" dirty="0"/>
-          </a:p>
-          <a:p>
-            <a:pPr algn="l" indent="0" marL="0">
-              <a:lnSpc>
-                <a:spcPts val="3600"/>
-              </a:lnSpc>
-              <a:spcAft>
-                <a:spcPts val="1000"/>
-              </a:spcAft>
-              <a:buNone/>
-            </a:pPr>
-            <a:endParaRPr lang="en-US" sz="1800" dirty="0"/>
-          </a:p>
-          <a:p>
-            <a:pPr algn="l" indent="0" marL="0">
-              <a:lnSpc>
-                <a:spcPts val="3600"/>
-              </a:lnSpc>
-              <a:spcAft>
-                <a:spcPts val="1000"/>
-              </a:spcAft>
-              <a:buNone/>
-            </a:pPr>
-            <a:r>
-              <a:rPr lang="en-US" sz="1800" dirty="0">
-                <a:solidFill>
-                  <a:srgbClr val="8C8578"/>
-                </a:solidFill>
-                <a:latin typeface="Courier New" pitchFamily="34" charset="0"/>
-                <a:ea typeface="Courier New" pitchFamily="34" charset="-122"/>
-                <a:cs typeface="Courier New" pitchFamily="34" charset="-120"/>
-              </a:rPr>
-              <a:t>· </a:t>
-            </a:r>
-            <a:pPr algn="l" indent="0" marL="0">
-              <a:lnSpc>
-                <a:spcPts val="3600"/>
-              </a:lnSpc>
-              <a:spcAft>
-                <a:spcPts val="1000"/>
-              </a:spcAft>
-              <a:buNone/>
-            </a:pPr>
-            <a:r>
-              <a:rPr lang="en-US" sz="1800" dirty="0">
-                <a:solidFill>
-                  <a:srgbClr val="F5F1EA"/>
-                </a:solidFill>
-                <a:latin typeface="Courier New" pitchFamily="34" charset="0"/>
-                <a:ea typeface="Courier New" pitchFamily="34" charset="-122"/>
-                <a:cs typeface="Courier New" pitchFamily="34" charset="-120"/>
-              </a:rPr>
-              <a:t>claude code 101</a:t>
-            </a:r>
-            <a:endParaRPr lang="en-US" sz="1800" dirty="0"/>
-          </a:p>
-          <a:p>
-            <a:pPr algn="l" indent="0" marL="0">
-              <a:lnSpc>
-                <a:spcPts val="3600"/>
-              </a:lnSpc>
-              <a:spcAft>
-                <a:spcPts val="1000"/>
-              </a:spcAft>
-              <a:buNone/>
-            </a:pPr>
-            <a:r>
-              <a:rPr lang="en-US" sz="1800" dirty="0">
-                <a:solidFill>
-                  <a:srgbClr val="8C8578"/>
-                </a:solidFill>
-                <a:latin typeface="Courier New" pitchFamily="34" charset="0"/>
-                <a:ea typeface="Courier New" pitchFamily="34" charset="-122"/>
-                <a:cs typeface="Courier New" pitchFamily="34" charset="-120"/>
-              </a:rPr>
-              <a:t>· </a:t>
-            </a:r>
-            <a:pPr algn="l" indent="0" marL="0">
-              <a:lnSpc>
-                <a:spcPts val="3600"/>
-              </a:lnSpc>
-              <a:spcAft>
-                <a:spcPts val="1000"/>
-              </a:spcAft>
-              <a:buNone/>
-            </a:pPr>
-            <a:r>
-              <a:rPr lang="en-US" sz="1800" dirty="0">
-                <a:solidFill>
-                  <a:srgbClr val="F5F1EA"/>
-                </a:solidFill>
-                <a:latin typeface="Courier New" pitchFamily="34" charset="0"/>
-                <a:ea typeface="Courier New" pitchFamily="34" charset="-122"/>
-                <a:cs typeface="Courier New" pitchFamily="34" charset="-120"/>
-              </a:rPr>
-              <a:t>claude code in action</a:t>
-            </a:r>
-            <a:endParaRPr lang="en-US" sz="1800" dirty="0"/>
-          </a:p>
-          <a:p>
-            <a:pPr algn="l" indent="0" marL="0">
-              <a:lnSpc>
-                <a:spcPts val="3600"/>
-              </a:lnSpc>
-              <a:spcAft>
-                <a:spcPts val="1000"/>
-              </a:spcAft>
-              <a:buNone/>
-            </a:pPr>
-            <a:r>
-              <a:rPr lang="en-US" sz="1800" dirty="0">
-                <a:solidFill>
-                  <a:srgbClr val="8C8578"/>
-                </a:solidFill>
-                <a:latin typeface="Courier New" pitchFamily="34" charset="0"/>
-                <a:ea typeface="Courier New" pitchFamily="34" charset="-122"/>
-                <a:cs typeface="Courier New" pitchFamily="34" charset="-120"/>
-              </a:rPr>
-              <a:t>· </a:t>
-            </a:r>
-            <a:pPr algn="l" indent="0" marL="0">
-              <a:lnSpc>
-                <a:spcPts val="3600"/>
-              </a:lnSpc>
-              <a:spcAft>
-                <a:spcPts val="1000"/>
-              </a:spcAft>
-              <a:buNone/>
-            </a:pPr>
-            <a:r>
-              <a:rPr lang="en-US" sz="1800" dirty="0">
-                <a:solidFill>
-                  <a:srgbClr val="F5F1EA"/>
-                </a:solidFill>
-                <a:latin typeface="Courier New" pitchFamily="34" charset="0"/>
-                <a:ea typeface="Courier New" pitchFamily="34" charset="-122"/>
-                <a:cs typeface="Courier New" pitchFamily="34" charset="-120"/>
-              </a:rPr>
-              <a:t>introduction to subagents</a:t>
-            </a:r>
-            <a:endParaRPr lang="en-US" sz="1800" dirty="0"/>
-          </a:p>
-          <a:p>
-            <a:pPr algn="l" indent="0" marL="0">
-              <a:lnSpc>
-                <a:spcPts val="3600"/>
-              </a:lnSpc>
-              <a:spcAft>
-                <a:spcPts val="1000"/>
-              </a:spcAft>
-              <a:buNone/>
-            </a:pPr>
-            <a:r>
-              <a:rPr lang="en-US" sz="1800" dirty="0">
-                <a:solidFill>
-                  <a:srgbClr val="8C8578"/>
-                </a:solidFill>
-                <a:latin typeface="Courier New" pitchFamily="34" charset="0"/>
-                <a:ea typeface="Courier New" pitchFamily="34" charset="-122"/>
-                <a:cs typeface="Courier New" pitchFamily="34" charset="-120"/>
-              </a:rPr>
-              <a:t>· </a:t>
-            </a:r>
-            <a:pPr algn="l" indent="0" marL="0">
-              <a:lnSpc>
-                <a:spcPts val="3600"/>
-              </a:lnSpc>
-              <a:spcAft>
-                <a:spcPts val="1000"/>
-              </a:spcAft>
-              <a:buNone/>
-            </a:pPr>
-            <a:r>
-              <a:rPr lang="en-US" sz="1800" dirty="0">
-                <a:solidFill>
-                  <a:srgbClr val="F5F1EA"/>
-                </a:solidFill>
-                <a:latin typeface="Courier New" pitchFamily="34" charset="0"/>
-                <a:ea typeface="Courier New" pitchFamily="34" charset="-122"/>
-                <a:cs typeface="Courier New" pitchFamily="34" charset="-120"/>
-              </a:rPr>
-              <a:t>introduction to agent skills</a:t>
-            </a:r>
-            <a:endParaRPr lang="en-US" sz="1800" dirty="0"/>
+              <a:t>design → code, without rewriting markup by hand</a:t>
+            </a:r>
+            <a:endParaRPr lang="en-US" sz="1900" dirty="0"/>
           </a:p>
         </p:txBody>
       </p:sp>
@@ -7027,11 +7125,11 @@
           <a:bodyPr wrap="square" lIns="0" tIns="0" rIns="0" bIns="0" rtlCol="0" anchor="ctr"/>
           <a:lstStyle/>
           <a:p>
-            <a:pPr algn="l" indent="0" marL="0">
-              <a:buNone/>
-            </a:pPr>
-            <a:r>
-              <a:rPr lang="en-US" sz="3000" b="1" dirty="0">
+            <a:pPr indent="0" marL="0">
+              <a:buNone/>
+            </a:pPr>
+            <a:r>
+              <a:rPr lang="en-US" sz="2800" b="1" dirty="0">
                 <a:solidFill>
                   <a:srgbClr val="F5F1EA"/>
                 </a:solidFill>
@@ -7039,9 +7137,9 @@
                 <a:ea typeface="Courier New" pitchFamily="34" charset="-122"/>
                 <a:cs typeface="Courier New" pitchFamily="34" charset="-120"/>
               </a:rPr>
-              <a:t>takeaways</a:t>
-            </a:r>
-            <a:endParaRPr lang="en-US" sz="3000" dirty="0"/>
+              <a:t>first: extract your project's style guide</a:t>
+            </a:r>
+            <a:endParaRPr lang="en-US" sz="2800" dirty="0"/>
           </a:p>
         </p:txBody>
       </p:sp>
@@ -7053,8 +7151,8 @@
         </p:nvSpPr>
         <p:spPr>
           <a:xfrm>
-            <a:off x="822960" y="2011680"/>
-            <a:ext cx="10543032" cy="4206240"/>
+            <a:off x="822960" y="1920240"/>
+            <a:ext cx="10543032" cy="457200"/>
           </a:xfrm>
           <a:prstGeom prst="rect">
             <a:avLst/>
@@ -7063,16 +7161,10 @@
           <a:ln/>
         </p:spPr>
         <p:txBody>
-          <a:bodyPr wrap="square" lIns="0" tIns="0" rIns="0" bIns="0" rtlCol="0" anchor="t"/>
-          <a:lstStyle/>
-          <a:p>
-            <a:pPr algn="l" indent="0" marL="0">
-              <a:lnSpc>
-                <a:spcPts val="4200"/>
-              </a:lnSpc>
-              <a:spcAft>
-                <a:spcPts val="1000"/>
-              </a:spcAft>
+          <a:bodyPr wrap="square" lIns="0" tIns="0" rIns="0" bIns="0" rtlCol="0" anchor="ctr"/>
+          <a:lstStyle/>
+          <a:p>
+            <a:pPr indent="0" marL="0">
               <a:buNone/>
             </a:pPr>
             <a:r>
@@ -7084,15 +7176,9 @@
                 <a:ea typeface="Courier New" pitchFamily="34" charset="-122"/>
                 <a:cs typeface="Courier New" pitchFamily="34" charset="-120"/>
               </a:rPr>
-              <a:t>1. </a:t>
-            </a:r>
-            <a:pPr algn="l" indent="0" marL="0">
-              <a:lnSpc>
-                <a:spcPts val="4200"/>
-              </a:lnSpc>
-              <a:spcAft>
-                <a:spcPts val="1000"/>
-              </a:spcAft>
+              <a:t>$ </a:t>
+            </a:r>
+            <a:pPr indent="0" marL="0">
               <a:buNone/>
             </a:pPr>
             <a:r>
@@ -7104,158 +7190,153 @@
                 <a:ea typeface="Courier New" pitchFamily="34" charset="-122"/>
                 <a:cs typeface="Courier New" pitchFamily="34" charset="-120"/>
               </a:rPr>
-              <a:t>claude code doesn't replace your judgment — review the diff</a:t>
+              <a:t>claude</a:t>
             </a:r>
             <a:endParaRPr lang="en-US" sz="1800" dirty="0"/>
           </a:p>
-          <a:p>
-            <a:pPr algn="l" indent="0" marL="0">
-              <a:lnSpc>
-                <a:spcPts val="4200"/>
-              </a:lnSpc>
-              <a:spcAft>
-                <a:spcPts val="1000"/>
-              </a:spcAft>
+        </p:txBody>
+      </p:sp>
+      <p:sp>
+        <p:nvSpPr>
+          <p:cNvPr id="5" name="Text 3"/>
+          <p:cNvSpPr/>
+          <p:nvPr/>
+        </p:nvSpPr>
+        <p:spPr>
+          <a:xfrm>
+            <a:off x="822960" y="2560320"/>
+            <a:ext cx="10543032" cy="1463040"/>
+          </a:xfrm>
+          <a:prstGeom prst="rect">
+            <a:avLst/>
+          </a:prstGeom>
+          <a:noFill/>
+          <a:ln/>
+        </p:spPr>
+        <p:txBody>
+          <a:bodyPr wrap="square" lIns="0" tIns="0" rIns="0" bIns="0" rtlCol="0" anchor="ctr"/>
+          <a:lstStyle/>
+          <a:p>
+            <a:pPr indent="0" marL="0">
+              <a:lnSpc>
+                <a:spcPts val="3200"/>
+              </a:lnSpc>
               <a:buNone/>
             </a:pPr>
             <a:r>
               <a:rPr lang="en-US" sz="1800" dirty="0">
                 <a:solidFill>
-                  <a:srgbClr val="8C8578"/>
-                </a:solidFill>
-                <a:latin typeface="Courier New" pitchFamily="34" charset="0"/>
-                <a:ea typeface="Courier New" pitchFamily="34" charset="-122"/>
-                <a:cs typeface="Courier New" pitchFamily="34" charset="-120"/>
-              </a:rPr>
-              <a:t>2. </a:t>
-            </a:r>
-            <a:pPr algn="l" indent="0" marL="0">
-              <a:lnSpc>
-                <a:spcPts val="4200"/>
-              </a:lnSpc>
-              <a:spcAft>
-                <a:spcPts val="1000"/>
-              </a:spcAft>
+                  <a:srgbClr val="D97757"/>
+                </a:solidFill>
+                <a:latin typeface="Courier New" pitchFamily="34" charset="0"/>
+                <a:ea typeface="Courier New" pitchFamily="34" charset="-122"/>
+                <a:cs typeface="Courier New" pitchFamily="34" charset="-120"/>
+              </a:rPr>
+              <a:t>"analyze this project's ui and write a style-guide.md:</a:t>
+            </a:r>
+            <a:endParaRPr lang="en-US" sz="1800" dirty="0"/>
+          </a:p>
+          <a:p>
+            <a:pPr indent="0" marL="0">
+              <a:lnSpc>
+                <a:spcPts val="3200"/>
+              </a:lnSpc>
               <a:buNone/>
             </a:pPr>
             <a:r>
               <a:rPr lang="en-US" sz="1800" dirty="0">
                 <a:solidFill>
+                  <a:srgbClr val="D97757"/>
+                </a:solidFill>
+                <a:latin typeface="Courier New" pitchFamily="34" charset="0"/>
+                <a:ea typeface="Courier New" pitchFamily="34" charset="-122"/>
+                <a:cs typeface="Courier New" pitchFamily="34" charset="-120"/>
+              </a:rPr>
+              <a:t> colors, typography, spacing, component patterns,</a:t>
+            </a:r>
+            <a:endParaRPr lang="en-US" sz="1800" dirty="0"/>
+          </a:p>
+          <a:p>
+            <a:pPr indent="0" marL="0">
+              <a:lnSpc>
+                <a:spcPts val="3200"/>
+              </a:lnSpc>
+              <a:buNone/>
+            </a:pPr>
+            <a:r>
+              <a:rPr lang="en-US" sz="1800" dirty="0">
+                <a:solidFill>
+                  <a:srgbClr val="D97757"/>
+                </a:solidFill>
+                <a:latin typeface="Courier New" pitchFamily="34" charset="0"/>
+                <a:ea typeface="Courier New" pitchFamily="34" charset="-122"/>
+                <a:cs typeface="Courier New" pitchFamily="34" charset="-120"/>
+              </a:rPr>
+              <a:t> naming conventions. single self-contained file."</a:t>
+            </a:r>
+            <a:endParaRPr lang="en-US" sz="1800" dirty="0"/>
+          </a:p>
+        </p:txBody>
+      </p:sp>
+      <p:sp>
+        <p:nvSpPr>
+          <p:cNvPr id="6" name="Text 4"/>
+          <p:cNvSpPr/>
+          <p:nvPr/>
+        </p:nvSpPr>
+        <p:spPr>
+          <a:xfrm>
+            <a:off x="822960" y="4663440"/>
+            <a:ext cx="10543032" cy="914400"/>
+          </a:xfrm>
+          <a:prstGeom prst="rect">
+            <a:avLst/>
+          </a:prstGeom>
+          <a:noFill/>
+          <a:ln/>
+        </p:spPr>
+        <p:txBody>
+          <a:bodyPr wrap="square" lIns="0" tIns="0" rIns="0" bIns="0" rtlCol="0" anchor="ctr"/>
+          <a:lstStyle/>
+          <a:p>
+            <a:pPr indent="0" marL="0">
+              <a:lnSpc>
+                <a:spcPts val="2800"/>
+              </a:lnSpc>
+              <a:buNone/>
+            </a:pPr>
+            <a:r>
+              <a:rPr lang="en-US" sz="1600" dirty="0">
+                <a:solidFill>
                   <a:srgbClr val="F5F1EA"/>
                 </a:solidFill>
                 <a:latin typeface="Courier New" pitchFamily="34" charset="0"/>
                 <a:ea typeface="Courier New" pitchFamily="34" charset="-122"/>
                 <a:cs typeface="Courier New" pitchFamily="34" charset="-120"/>
               </a:rPr>
-              <a:t>start with a good CLAUDE.md and prompts with real context</a:t>
-            </a:r>
-            <a:endParaRPr lang="en-US" sz="1800" dirty="0"/>
-          </a:p>
-          <a:p>
-            <a:pPr algn="l" indent="0" marL="0">
-              <a:lnSpc>
-                <a:spcPts val="4200"/>
-              </a:lnSpc>
-              <a:spcAft>
-                <a:spcPts val="1000"/>
-              </a:spcAft>
-              <a:buNone/>
-            </a:pPr>
-            <a:r>
-              <a:rPr lang="en-US" sz="1800" dirty="0">
-                <a:solidFill>
-                  <a:srgbClr val="8C8578"/>
-                </a:solidFill>
-                <a:latin typeface="Courier New" pitchFamily="34" charset="0"/>
-                <a:ea typeface="Courier New" pitchFamily="34" charset="-122"/>
-                <a:cs typeface="Courier New" pitchFamily="34" charset="-120"/>
-              </a:rPr>
-              <a:t>3. </a:t>
-            </a:r>
-            <a:pPr algn="l" indent="0" marL="0">
-              <a:lnSpc>
-                <a:spcPts val="4200"/>
-              </a:lnSpc>
-              <a:spcAft>
-                <a:spcPts val="1000"/>
-              </a:spcAft>
-              <a:buNone/>
-            </a:pPr>
-            <a:r>
-              <a:rPr lang="en-US" sz="1800" dirty="0">
-                <a:solidFill>
-                  <a:srgbClr val="F5F1EA"/>
-                </a:solidFill>
-                <a:latin typeface="Courier New" pitchFamily="34" charset="0"/>
-                <a:ea typeface="Courier New" pitchFamily="34" charset="-122"/>
-                <a:cs typeface="Courier New" pitchFamily="34" charset="-120"/>
-              </a:rPr>
-              <a:t>plan mode for the ambiguous, act for the clear</a:t>
-            </a:r>
-            <a:endParaRPr lang="en-US" sz="1800" dirty="0"/>
-          </a:p>
-          <a:p>
-            <a:pPr algn="l" indent="0" marL="0">
-              <a:lnSpc>
-                <a:spcPts val="4200"/>
-              </a:lnSpc>
-              <a:spcAft>
-                <a:spcPts val="1000"/>
-              </a:spcAft>
-              <a:buNone/>
-            </a:pPr>
-            <a:r>
-              <a:rPr lang="en-US" sz="1800" dirty="0">
-                <a:solidFill>
-                  <a:srgbClr val="8C8578"/>
-                </a:solidFill>
-                <a:latin typeface="Courier New" pitchFamily="34" charset="0"/>
-                <a:ea typeface="Courier New" pitchFamily="34" charset="-122"/>
-                <a:cs typeface="Courier New" pitchFamily="34" charset="-120"/>
-              </a:rPr>
-              <a:t>4. </a:t>
-            </a:r>
-            <a:pPr algn="l" indent="0" marL="0">
-              <a:lnSpc>
-                <a:spcPts val="4200"/>
-              </a:lnSpc>
-              <a:spcAft>
-                <a:spcPts val="1000"/>
-              </a:spcAft>
-              <a:buNone/>
-            </a:pPr>
-            <a:r>
-              <a:rPr lang="en-US" sz="1800" dirty="0">
-                <a:solidFill>
-                  <a:srgbClr val="F5F1EA"/>
-                </a:solidFill>
-                <a:latin typeface="Courier New" pitchFamily="34" charset="0"/>
-                <a:ea typeface="Courier New" pitchFamily="34" charset="-122"/>
-                <a:cs typeface="Courier New" pitchFamily="34" charset="-120"/>
-              </a:rPr>
-              <a:t>mcp-dedalo is live — </a:t>
-            </a:r>
-            <a:pPr algn="l" indent="0" marL="0">
-              <a:lnSpc>
-                <a:spcPts val="4200"/>
-              </a:lnSpc>
-              <a:spcAft>
-                <a:spcPts val="1000"/>
-              </a:spcAft>
-              <a:buNone/>
-            </a:pPr>
-            <a:r>
-              <a:rPr lang="en-US" sz="1800" dirty="0">
-                <a:solidFill>
-                  <a:srgbClr val="D97757"/>
-                </a:solidFill>
-                <a:latin typeface="Courier New" pitchFamily="34" charset="0"/>
-                <a:ea typeface="Courier New" pitchFamily="34" charset="-122"/>
-                <a:cs typeface="Courier New" pitchFamily="34" charset="-120"/>
-              </a:rPr>
-              <a:t>try it this week</a:t>
-            </a:r>
-            <a:endParaRPr lang="en-US" sz="1800" dirty="0"/>
+              <a:t>upload it to claude.ai/design →</a:t>
+            </a:r>
+            <a:endParaRPr lang="en-US" sz="1600" dirty="0"/>
+          </a:p>
+          <a:p>
+            <a:pPr indent="0" marL="0">
+              <a:lnSpc>
+                <a:spcPts val="2800"/>
+              </a:lnSpc>
+              <a:buNone/>
+            </a:pPr>
+            <a:r>
+              <a:rPr lang="en-US" sz="1600" dirty="0">
+                <a:solidFill>
+                  <a:srgbClr val="8C8578"/>
+                </a:solidFill>
+                <a:latin typeface="Courier New" pitchFamily="34" charset="0"/>
+                <a:ea typeface="Courier New" pitchFamily="34" charset="-122"/>
+                <a:cs typeface="Courier New" pitchFamily="34" charset="-120"/>
+              </a:rPr>
+              <a:t>every design it generates matches your product</a:t>
+            </a:r>
+            <a:endParaRPr lang="en-US" sz="1600" dirty="0"/>
           </a:p>
         </p:txBody>
       </p:sp>
@@ -7318,6 +7399,675 @@
                 <a:cs typeface="Courier New" pitchFamily="34" charset="-120"/>
               </a:rPr>
               <a:t>23</a:t>
+            </a:r>
+            <a:endParaRPr lang="en-US" sz="1100" dirty="0"/>
+          </a:p>
+        </p:txBody>
+      </p:sp>
+      <p:sp>
+        <p:nvSpPr>
+          <p:cNvPr id="3" name="Text 1"/>
+          <p:cNvSpPr/>
+          <p:nvPr/>
+        </p:nvSpPr>
+        <p:spPr>
+          <a:xfrm>
+            <a:off x="822960" y="685800"/>
+            <a:ext cx="10543032" cy="822960"/>
+          </a:xfrm>
+          <a:prstGeom prst="rect">
+            <a:avLst/>
+          </a:prstGeom>
+          <a:noFill/>
+          <a:ln/>
+        </p:spPr>
+        <p:txBody>
+          <a:bodyPr wrap="square" lIns="0" tIns="0" rIns="0" bIns="0" rtlCol="0" anchor="ctr"/>
+          <a:lstStyle/>
+          <a:p>
+            <a:pPr algn="l" indent="0" marL="0">
+              <a:buNone/>
+            </a:pPr>
+            <a:r>
+              <a:rPr lang="en-US" sz="3000" b="1" dirty="0">
+                <a:solidFill>
+                  <a:srgbClr val="F5F1EA"/>
+                </a:solidFill>
+                <a:latin typeface="Courier New" pitchFamily="34" charset="0"/>
+                <a:ea typeface="Courier New" pitchFamily="34" charset="-122"/>
+                <a:cs typeface="Courier New" pitchFamily="34" charset="-120"/>
+              </a:rPr>
+              <a:t>learn more</a:t>
+            </a:r>
+            <a:endParaRPr lang="en-US" sz="3000" dirty="0"/>
+          </a:p>
+        </p:txBody>
+      </p:sp>
+      <p:sp>
+        <p:nvSpPr>
+          <p:cNvPr id="4" name="Text 2"/>
+          <p:cNvSpPr/>
+          <p:nvPr/>
+        </p:nvSpPr>
+        <p:spPr>
+          <a:xfrm>
+            <a:off x="822960" y="1828800"/>
+            <a:ext cx="10543032" cy="4389120"/>
+          </a:xfrm>
+          <a:prstGeom prst="rect">
+            <a:avLst/>
+          </a:prstGeom>
+          <a:noFill/>
+          <a:ln/>
+        </p:spPr>
+        <p:txBody>
+          <a:bodyPr wrap="square" lIns="0" tIns="0" rIns="0" bIns="0" rtlCol="0" anchor="t"/>
+          <a:lstStyle/>
+          <a:p>
+            <a:pPr algn="l" indent="0" marL="0">
+              <a:lnSpc>
+                <a:spcPts val="3600"/>
+              </a:lnSpc>
+              <a:spcAft>
+                <a:spcPts val="1000"/>
+              </a:spcAft>
+              <a:buNone/>
+            </a:pPr>
+            <a:r>
+              <a:rPr lang="en-US" sz="1800" dirty="0">
+                <a:solidFill>
+                  <a:srgbClr val="D97757"/>
+                </a:solidFill>
+                <a:latin typeface="Courier New" pitchFamily="34" charset="0"/>
+                <a:ea typeface="Courier New" pitchFamily="34" charset="-122"/>
+                <a:cs typeface="Courier New" pitchFamily="34" charset="-120"/>
+              </a:rPr>
+              <a:t>anthropic.skilljar.com</a:t>
+            </a:r>
+            <a:pPr algn="l" indent="0" marL="0">
+              <a:lnSpc>
+                <a:spcPts val="3600"/>
+              </a:lnSpc>
+              <a:spcAft>
+                <a:spcPts val="1000"/>
+              </a:spcAft>
+              <a:buNone/>
+            </a:pPr>
+            <a:r>
+              <a:rPr lang="en-US" sz="1800" dirty="0">
+                <a:solidFill>
+                  <a:srgbClr val="8C8578"/>
+                </a:solidFill>
+                <a:latin typeface="Courier New" pitchFamily="34" charset="0"/>
+                <a:ea typeface="Courier New" pitchFamily="34" charset="-122"/>
+                <a:cs typeface="Courier New" pitchFamily="34" charset="-120"/>
+              </a:rPr>
+              <a:t>   free official courses, certificate</a:t>
+            </a:r>
+            <a:endParaRPr lang="en-US" sz="1800" dirty="0"/>
+          </a:p>
+          <a:p>
+            <a:pPr algn="l" indent="0" marL="0">
+              <a:lnSpc>
+                <a:spcPts val="3600"/>
+              </a:lnSpc>
+              <a:spcAft>
+                <a:spcPts val="1000"/>
+              </a:spcAft>
+              <a:buNone/>
+            </a:pPr>
+            <a:endParaRPr lang="en-US" sz="1800" dirty="0"/>
+          </a:p>
+          <a:p>
+            <a:pPr algn="l" indent="0" marL="0">
+              <a:lnSpc>
+                <a:spcPts val="3600"/>
+              </a:lnSpc>
+              <a:spcAft>
+                <a:spcPts val="1000"/>
+              </a:spcAft>
+              <a:buNone/>
+            </a:pPr>
+            <a:r>
+              <a:rPr lang="en-US" sz="1800" dirty="0">
+                <a:solidFill>
+                  <a:srgbClr val="8C8578"/>
+                </a:solidFill>
+                <a:latin typeface="Courier New" pitchFamily="34" charset="0"/>
+                <a:ea typeface="Courier New" pitchFamily="34" charset="-122"/>
+                <a:cs typeface="Courier New" pitchFamily="34" charset="-120"/>
+              </a:rPr>
+              <a:t>· </a:t>
+            </a:r>
+            <a:pPr algn="l" indent="0" marL="0">
+              <a:lnSpc>
+                <a:spcPts val="3600"/>
+              </a:lnSpc>
+              <a:spcAft>
+                <a:spcPts val="1000"/>
+              </a:spcAft>
+              <a:buNone/>
+            </a:pPr>
+            <a:r>
+              <a:rPr lang="en-US" sz="1800" dirty="0">
+                <a:solidFill>
+                  <a:srgbClr val="F5F1EA"/>
+                </a:solidFill>
+                <a:latin typeface="Courier New" pitchFamily="34" charset="0"/>
+                <a:ea typeface="Courier New" pitchFamily="34" charset="-122"/>
+                <a:cs typeface="Courier New" pitchFamily="34" charset="-120"/>
+              </a:rPr>
+              <a:t>claude code 101</a:t>
+            </a:r>
+            <a:endParaRPr lang="en-US" sz="1800" dirty="0"/>
+          </a:p>
+          <a:p>
+            <a:pPr algn="l" indent="0" marL="0">
+              <a:lnSpc>
+                <a:spcPts val="3600"/>
+              </a:lnSpc>
+              <a:spcAft>
+                <a:spcPts val="1000"/>
+              </a:spcAft>
+              <a:buNone/>
+            </a:pPr>
+            <a:r>
+              <a:rPr lang="en-US" sz="1800" dirty="0">
+                <a:solidFill>
+                  <a:srgbClr val="8C8578"/>
+                </a:solidFill>
+                <a:latin typeface="Courier New" pitchFamily="34" charset="0"/>
+                <a:ea typeface="Courier New" pitchFamily="34" charset="-122"/>
+                <a:cs typeface="Courier New" pitchFamily="34" charset="-120"/>
+              </a:rPr>
+              <a:t>· </a:t>
+            </a:r>
+            <a:pPr algn="l" indent="0" marL="0">
+              <a:lnSpc>
+                <a:spcPts val="3600"/>
+              </a:lnSpc>
+              <a:spcAft>
+                <a:spcPts val="1000"/>
+              </a:spcAft>
+              <a:buNone/>
+            </a:pPr>
+            <a:r>
+              <a:rPr lang="en-US" sz="1800" dirty="0">
+                <a:solidFill>
+                  <a:srgbClr val="F5F1EA"/>
+                </a:solidFill>
+                <a:latin typeface="Courier New" pitchFamily="34" charset="0"/>
+                <a:ea typeface="Courier New" pitchFamily="34" charset="-122"/>
+                <a:cs typeface="Courier New" pitchFamily="34" charset="-120"/>
+              </a:rPr>
+              <a:t>claude code in action</a:t>
+            </a:r>
+            <a:endParaRPr lang="en-US" sz="1800" dirty="0"/>
+          </a:p>
+          <a:p>
+            <a:pPr algn="l" indent="0" marL="0">
+              <a:lnSpc>
+                <a:spcPts val="3600"/>
+              </a:lnSpc>
+              <a:spcAft>
+                <a:spcPts val="1000"/>
+              </a:spcAft>
+              <a:buNone/>
+            </a:pPr>
+            <a:r>
+              <a:rPr lang="en-US" sz="1800" dirty="0">
+                <a:solidFill>
+                  <a:srgbClr val="8C8578"/>
+                </a:solidFill>
+                <a:latin typeface="Courier New" pitchFamily="34" charset="0"/>
+                <a:ea typeface="Courier New" pitchFamily="34" charset="-122"/>
+                <a:cs typeface="Courier New" pitchFamily="34" charset="-120"/>
+              </a:rPr>
+              <a:t>· </a:t>
+            </a:r>
+            <a:pPr algn="l" indent="0" marL="0">
+              <a:lnSpc>
+                <a:spcPts val="3600"/>
+              </a:lnSpc>
+              <a:spcAft>
+                <a:spcPts val="1000"/>
+              </a:spcAft>
+              <a:buNone/>
+            </a:pPr>
+            <a:r>
+              <a:rPr lang="en-US" sz="1800" dirty="0">
+                <a:solidFill>
+                  <a:srgbClr val="F5F1EA"/>
+                </a:solidFill>
+                <a:latin typeface="Courier New" pitchFamily="34" charset="0"/>
+                <a:ea typeface="Courier New" pitchFamily="34" charset="-122"/>
+                <a:cs typeface="Courier New" pitchFamily="34" charset="-120"/>
+              </a:rPr>
+              <a:t>introduction to subagents</a:t>
+            </a:r>
+            <a:endParaRPr lang="en-US" sz="1800" dirty="0"/>
+          </a:p>
+          <a:p>
+            <a:pPr algn="l" indent="0" marL="0">
+              <a:lnSpc>
+                <a:spcPts val="3600"/>
+              </a:lnSpc>
+              <a:spcAft>
+                <a:spcPts val="1000"/>
+              </a:spcAft>
+              <a:buNone/>
+            </a:pPr>
+            <a:r>
+              <a:rPr lang="en-US" sz="1800" dirty="0">
+                <a:solidFill>
+                  <a:srgbClr val="8C8578"/>
+                </a:solidFill>
+                <a:latin typeface="Courier New" pitchFamily="34" charset="0"/>
+                <a:ea typeface="Courier New" pitchFamily="34" charset="-122"/>
+                <a:cs typeface="Courier New" pitchFamily="34" charset="-120"/>
+              </a:rPr>
+              <a:t>· </a:t>
+            </a:r>
+            <a:pPr algn="l" indent="0" marL="0">
+              <a:lnSpc>
+                <a:spcPts val="3600"/>
+              </a:lnSpc>
+              <a:spcAft>
+                <a:spcPts val="1000"/>
+              </a:spcAft>
+              <a:buNone/>
+            </a:pPr>
+            <a:r>
+              <a:rPr lang="en-US" sz="1800" dirty="0">
+                <a:solidFill>
+                  <a:srgbClr val="F5F1EA"/>
+                </a:solidFill>
+                <a:latin typeface="Courier New" pitchFamily="34" charset="0"/>
+                <a:ea typeface="Courier New" pitchFamily="34" charset="-122"/>
+                <a:cs typeface="Courier New" pitchFamily="34" charset="-120"/>
+              </a:rPr>
+              <a:t>introduction to agent skills</a:t>
+            </a:r>
+            <a:endParaRPr lang="en-US" sz="1800" dirty="0"/>
+          </a:p>
+        </p:txBody>
+      </p:sp>
+    </p:spTree>
+  </p:cSld>
+  <p:clrMapOvr>
+    <a:masterClrMapping/>
+  </p:clrMapOvr>
+</p:sld>
+</file>
+
+<file path=ppt/slides/slide24.xml><?xml version="1.0" encoding="utf-8"?>
+<p:sld xmlns:a="http://schemas.openxmlformats.org/drawingml/2006/main" xmlns:r="http://schemas.openxmlformats.org/officeDocument/2006/relationships" xmlns:p="http://schemas.openxmlformats.org/presentationml/2006/main">
+  <p:cSld name="Slide 24">
+    <p:spTree>
+      <p:nvGrpSpPr>
+        <p:cNvPr id="1" name=""/>
+        <p:cNvGrpSpPr/>
+        <p:nvPr/>
+      </p:nvGrpSpPr>
+      <p:grpSpPr>
+        <a:xfrm>
+          <a:off x="0" y="0"/>
+          <a:ext cx="0" cy="0"/>
+          <a:chOff x="0" y="0"/>
+          <a:chExt cx="0" cy="0"/>
+        </a:xfrm>
+      </p:grpSpPr>
+      <p:sp>
+        <p:nvSpPr>
+          <p:cNvPr id="2" name="Text 0"/>
+          <p:cNvSpPr/>
+          <p:nvPr/>
+        </p:nvSpPr>
+        <p:spPr>
+          <a:xfrm>
+            <a:off x="11274552" y="6355080"/>
+            <a:ext cx="548640" cy="320040"/>
+          </a:xfrm>
+          <a:prstGeom prst="rect">
+            <a:avLst/>
+          </a:prstGeom>
+          <a:noFill/>
+          <a:ln/>
+        </p:spPr>
+        <p:txBody>
+          <a:bodyPr wrap="square" lIns="0" tIns="0" rIns="0" bIns="0" rtlCol="0" anchor="ctr"/>
+          <a:lstStyle/>
+          <a:p>
+            <a:pPr algn="r" indent="0" marL="0">
+              <a:buNone/>
+            </a:pPr>
+            <a:r>
+              <a:rPr lang="en-US" sz="1100" dirty="0">
+                <a:solidFill>
+                  <a:srgbClr val="8C8578"/>
+                </a:solidFill>
+                <a:latin typeface="Courier New" pitchFamily="34" charset="0"/>
+                <a:ea typeface="Courier New" pitchFamily="34" charset="-122"/>
+                <a:cs typeface="Courier New" pitchFamily="34" charset="-120"/>
+              </a:rPr>
+              <a:t>24</a:t>
+            </a:r>
+            <a:endParaRPr lang="en-US" sz="1100" dirty="0"/>
+          </a:p>
+        </p:txBody>
+      </p:sp>
+      <p:sp>
+        <p:nvSpPr>
+          <p:cNvPr id="3" name="Text 1"/>
+          <p:cNvSpPr/>
+          <p:nvPr/>
+        </p:nvSpPr>
+        <p:spPr>
+          <a:xfrm>
+            <a:off x="822960" y="685800"/>
+            <a:ext cx="10543032" cy="822960"/>
+          </a:xfrm>
+          <a:prstGeom prst="rect">
+            <a:avLst/>
+          </a:prstGeom>
+          <a:noFill/>
+          <a:ln/>
+        </p:spPr>
+        <p:txBody>
+          <a:bodyPr wrap="square" lIns="0" tIns="0" rIns="0" bIns="0" rtlCol="0" anchor="ctr"/>
+          <a:lstStyle/>
+          <a:p>
+            <a:pPr algn="l" indent="0" marL="0">
+              <a:buNone/>
+            </a:pPr>
+            <a:r>
+              <a:rPr lang="en-US" sz="3000" b="1" dirty="0">
+                <a:solidFill>
+                  <a:srgbClr val="F5F1EA"/>
+                </a:solidFill>
+                <a:latin typeface="Courier New" pitchFamily="34" charset="0"/>
+                <a:ea typeface="Courier New" pitchFamily="34" charset="-122"/>
+                <a:cs typeface="Courier New" pitchFamily="34" charset="-120"/>
+              </a:rPr>
+              <a:t>takeaways</a:t>
+            </a:r>
+            <a:endParaRPr lang="en-US" sz="3000" dirty="0"/>
+          </a:p>
+        </p:txBody>
+      </p:sp>
+      <p:sp>
+        <p:nvSpPr>
+          <p:cNvPr id="4" name="Text 2"/>
+          <p:cNvSpPr/>
+          <p:nvPr/>
+        </p:nvSpPr>
+        <p:spPr>
+          <a:xfrm>
+            <a:off x="822960" y="2011680"/>
+            <a:ext cx="10543032" cy="4206240"/>
+          </a:xfrm>
+          <a:prstGeom prst="rect">
+            <a:avLst/>
+          </a:prstGeom>
+          <a:noFill/>
+          <a:ln/>
+        </p:spPr>
+        <p:txBody>
+          <a:bodyPr wrap="square" lIns="0" tIns="0" rIns="0" bIns="0" rtlCol="0" anchor="t"/>
+          <a:lstStyle/>
+          <a:p>
+            <a:pPr algn="l" indent="0" marL="0">
+              <a:lnSpc>
+                <a:spcPts val="4200"/>
+              </a:lnSpc>
+              <a:spcAft>
+                <a:spcPts val="1000"/>
+              </a:spcAft>
+              <a:buNone/>
+            </a:pPr>
+            <a:r>
+              <a:rPr lang="en-US" sz="1800" dirty="0">
+                <a:solidFill>
+                  <a:srgbClr val="8C8578"/>
+                </a:solidFill>
+                <a:latin typeface="Courier New" pitchFamily="34" charset="0"/>
+                <a:ea typeface="Courier New" pitchFamily="34" charset="-122"/>
+                <a:cs typeface="Courier New" pitchFamily="34" charset="-120"/>
+              </a:rPr>
+              <a:t>1. </a:t>
+            </a:r>
+            <a:pPr algn="l" indent="0" marL="0">
+              <a:lnSpc>
+                <a:spcPts val="4200"/>
+              </a:lnSpc>
+              <a:spcAft>
+                <a:spcPts val="1000"/>
+              </a:spcAft>
+              <a:buNone/>
+            </a:pPr>
+            <a:r>
+              <a:rPr lang="en-US" sz="1800" dirty="0">
+                <a:solidFill>
+                  <a:srgbClr val="F5F1EA"/>
+                </a:solidFill>
+                <a:latin typeface="Courier New" pitchFamily="34" charset="0"/>
+                <a:ea typeface="Courier New" pitchFamily="34" charset="-122"/>
+                <a:cs typeface="Courier New" pitchFamily="34" charset="-120"/>
+              </a:rPr>
+              <a:t>claude code doesn't replace your judgment — review the diff</a:t>
+            </a:r>
+            <a:endParaRPr lang="en-US" sz="1800" dirty="0"/>
+          </a:p>
+          <a:p>
+            <a:pPr algn="l" indent="0" marL="0">
+              <a:lnSpc>
+                <a:spcPts val="4200"/>
+              </a:lnSpc>
+              <a:spcAft>
+                <a:spcPts val="1000"/>
+              </a:spcAft>
+              <a:buNone/>
+            </a:pPr>
+            <a:r>
+              <a:rPr lang="en-US" sz="1800" dirty="0">
+                <a:solidFill>
+                  <a:srgbClr val="8C8578"/>
+                </a:solidFill>
+                <a:latin typeface="Courier New" pitchFamily="34" charset="0"/>
+                <a:ea typeface="Courier New" pitchFamily="34" charset="-122"/>
+                <a:cs typeface="Courier New" pitchFamily="34" charset="-120"/>
+              </a:rPr>
+              <a:t>2. </a:t>
+            </a:r>
+            <a:pPr algn="l" indent="0" marL="0">
+              <a:lnSpc>
+                <a:spcPts val="4200"/>
+              </a:lnSpc>
+              <a:spcAft>
+                <a:spcPts val="1000"/>
+              </a:spcAft>
+              <a:buNone/>
+            </a:pPr>
+            <a:r>
+              <a:rPr lang="en-US" sz="1800" dirty="0">
+                <a:solidFill>
+                  <a:srgbClr val="F5F1EA"/>
+                </a:solidFill>
+                <a:latin typeface="Courier New" pitchFamily="34" charset="0"/>
+                <a:ea typeface="Courier New" pitchFamily="34" charset="-122"/>
+                <a:cs typeface="Courier New" pitchFamily="34" charset="-120"/>
+              </a:rPr>
+              <a:t>start with a good CLAUDE.md and prompts with real context</a:t>
+            </a:r>
+            <a:endParaRPr lang="en-US" sz="1800" dirty="0"/>
+          </a:p>
+          <a:p>
+            <a:pPr algn="l" indent="0" marL="0">
+              <a:lnSpc>
+                <a:spcPts val="4200"/>
+              </a:lnSpc>
+              <a:spcAft>
+                <a:spcPts val="1000"/>
+              </a:spcAft>
+              <a:buNone/>
+            </a:pPr>
+            <a:r>
+              <a:rPr lang="en-US" sz="1800" dirty="0">
+                <a:solidFill>
+                  <a:srgbClr val="8C8578"/>
+                </a:solidFill>
+                <a:latin typeface="Courier New" pitchFamily="34" charset="0"/>
+                <a:ea typeface="Courier New" pitchFamily="34" charset="-122"/>
+                <a:cs typeface="Courier New" pitchFamily="34" charset="-120"/>
+              </a:rPr>
+              <a:t>3. </a:t>
+            </a:r>
+            <a:pPr algn="l" indent="0" marL="0">
+              <a:lnSpc>
+                <a:spcPts val="4200"/>
+              </a:lnSpc>
+              <a:spcAft>
+                <a:spcPts val="1000"/>
+              </a:spcAft>
+              <a:buNone/>
+            </a:pPr>
+            <a:r>
+              <a:rPr lang="en-US" sz="1800" dirty="0">
+                <a:solidFill>
+                  <a:srgbClr val="F5F1EA"/>
+                </a:solidFill>
+                <a:latin typeface="Courier New" pitchFamily="34" charset="0"/>
+                <a:ea typeface="Courier New" pitchFamily="34" charset="-122"/>
+                <a:cs typeface="Courier New" pitchFamily="34" charset="-120"/>
+              </a:rPr>
+              <a:t>plan mode for the ambiguous, act for the clear</a:t>
+            </a:r>
+            <a:endParaRPr lang="en-US" sz="1800" dirty="0"/>
+          </a:p>
+          <a:p>
+            <a:pPr algn="l" indent="0" marL="0">
+              <a:lnSpc>
+                <a:spcPts val="4200"/>
+              </a:lnSpc>
+              <a:spcAft>
+                <a:spcPts val="1000"/>
+              </a:spcAft>
+              <a:buNone/>
+            </a:pPr>
+            <a:r>
+              <a:rPr lang="en-US" sz="1800" dirty="0">
+                <a:solidFill>
+                  <a:srgbClr val="8C8578"/>
+                </a:solidFill>
+                <a:latin typeface="Courier New" pitchFamily="34" charset="0"/>
+                <a:ea typeface="Courier New" pitchFamily="34" charset="-122"/>
+                <a:cs typeface="Courier New" pitchFamily="34" charset="-120"/>
+              </a:rPr>
+              <a:t>4. </a:t>
+            </a:r>
+            <a:pPr algn="l" indent="0" marL="0">
+              <a:lnSpc>
+                <a:spcPts val="4200"/>
+              </a:lnSpc>
+              <a:spcAft>
+                <a:spcPts val="1000"/>
+              </a:spcAft>
+              <a:buNone/>
+            </a:pPr>
+            <a:r>
+              <a:rPr lang="en-US" sz="1800" dirty="0">
+                <a:solidFill>
+                  <a:srgbClr val="F5F1EA"/>
+                </a:solidFill>
+                <a:latin typeface="Courier New" pitchFamily="34" charset="0"/>
+                <a:ea typeface="Courier New" pitchFamily="34" charset="-122"/>
+                <a:cs typeface="Courier New" pitchFamily="34" charset="-120"/>
+              </a:rPr>
+              <a:t>mcp-dedalo is live — </a:t>
+            </a:r>
+            <a:pPr algn="l" indent="0" marL="0">
+              <a:lnSpc>
+                <a:spcPts val="4200"/>
+              </a:lnSpc>
+              <a:spcAft>
+                <a:spcPts val="1000"/>
+              </a:spcAft>
+              <a:buNone/>
+            </a:pPr>
+            <a:r>
+              <a:rPr lang="en-US" sz="1800" dirty="0">
+                <a:solidFill>
+                  <a:srgbClr val="D97757"/>
+                </a:solidFill>
+                <a:latin typeface="Courier New" pitchFamily="34" charset="0"/>
+                <a:ea typeface="Courier New" pitchFamily="34" charset="-122"/>
+                <a:cs typeface="Courier New" pitchFamily="34" charset="-120"/>
+              </a:rPr>
+              <a:t>try it this week</a:t>
+            </a:r>
+            <a:endParaRPr lang="en-US" sz="1800" dirty="0"/>
+          </a:p>
+        </p:txBody>
+      </p:sp>
+    </p:spTree>
+  </p:cSld>
+  <p:clrMapOvr>
+    <a:masterClrMapping/>
+  </p:clrMapOvr>
+</p:sld>
+</file>
+
+<file path=ppt/slides/slide25.xml><?xml version="1.0" encoding="utf-8"?>
+<p:sld xmlns:a="http://schemas.openxmlformats.org/drawingml/2006/main" xmlns:r="http://schemas.openxmlformats.org/officeDocument/2006/relationships" xmlns:p="http://schemas.openxmlformats.org/presentationml/2006/main">
+  <p:cSld name="Slide 25">
+    <p:spTree>
+      <p:nvGrpSpPr>
+        <p:cNvPr id="1" name=""/>
+        <p:cNvGrpSpPr/>
+        <p:nvPr/>
+      </p:nvGrpSpPr>
+      <p:grpSpPr>
+        <a:xfrm>
+          <a:off x="0" y="0"/>
+          <a:ext cx="0" cy="0"/>
+          <a:chOff x="0" y="0"/>
+          <a:chExt cx="0" cy="0"/>
+        </a:xfrm>
+      </p:grpSpPr>
+      <p:sp>
+        <p:nvSpPr>
+          <p:cNvPr id="2" name="Text 0"/>
+          <p:cNvSpPr/>
+          <p:nvPr/>
+        </p:nvSpPr>
+        <p:spPr>
+          <a:xfrm>
+            <a:off x="11274552" y="6355080"/>
+            <a:ext cx="548640" cy="320040"/>
+          </a:xfrm>
+          <a:prstGeom prst="rect">
+            <a:avLst/>
+          </a:prstGeom>
+          <a:noFill/>
+          <a:ln/>
+        </p:spPr>
+        <p:txBody>
+          <a:bodyPr wrap="square" lIns="0" tIns="0" rIns="0" bIns="0" rtlCol="0" anchor="ctr"/>
+          <a:lstStyle/>
+          <a:p>
+            <a:pPr algn="r" indent="0" marL="0">
+              <a:buNone/>
+            </a:pPr>
+            <a:r>
+              <a:rPr lang="en-US" sz="1100" dirty="0">
+                <a:solidFill>
+                  <a:srgbClr val="8C8578"/>
+                </a:solidFill>
+                <a:latin typeface="Courier New" pitchFamily="34" charset="0"/>
+                <a:ea typeface="Courier New" pitchFamily="34" charset="-122"/>
+                <a:cs typeface="Courier New" pitchFamily="34" charset="-120"/>
+              </a:rPr>
+              <a:t>25</a:t>
             </a:r>
             <a:endParaRPr lang="en-US" sz="1100" dirty="0"/>
           </a:p>

</xml_diff>

<commit_message>
guión palabra por palabra + demo participativa dédalo + install ps1 y xhigh en el deck
Co-Authored-By: Claude Fable 5 <noreply@anthropic.com>
</commit_message>
<xml_diff>
--- a/claude-code-seminar.pptx
+++ b/claude-code-seminar.pptx
@@ -526,7 +526,7 @@
           <a:p>
             <a:r>
               <a:rPr lang="en-US" dirty="0"/>
-              <a:t>While people settle in, have them install Claude Code. Requires Node 18+.</a:t>
+              <a:t>While people settle in, have them install Claude Code. PowerShell one-liner, no prerequisites. (macOS/Linux: curl -fsSL https://claude.ai/install.sh | bash)</a:t>
             </a:r>
             <a:endParaRPr lang="en-US" dirty="0"/>
           </a:p>
@@ -3123,7 +3123,7 @@
                 <a:ea typeface="Courier New" pitchFamily="34" charset="-122"/>
                 <a:cs typeface="Courier New" pitchFamily="34" charset="-120"/>
               </a:rPr>
-              <a:t>npm install -g @anthropic-ai/claude-code</a:t>
+              <a:t>irm https://claude.ai/install.ps1 | iex</a:t>
             </a:r>
             <a:endParaRPr lang="en-US" sz="2400" dirty="0"/>
           </a:p>
@@ -9326,7 +9326,30 @@
                 <a:ea typeface="Courier New" pitchFamily="34" charset="-122"/>
                 <a:cs typeface="Courier New" pitchFamily="34" charset="-120"/>
               </a:rPr>
-              <a:t>                 (low / medium / high)</a:t>
+              <a:t>                 (low / medium / high / xhigh)</a:t>
+            </a:r>
+            <a:endParaRPr lang="en-US" sz="1800" dirty="0"/>
+          </a:p>
+          <a:p>
+            <a:pPr algn="l" indent="0" marL="0">
+              <a:lnSpc>
+                <a:spcPts val="3600"/>
+              </a:lnSpc>
+              <a:spcAft>
+                <a:spcPts val="1000"/>
+              </a:spcAft>
+              <a:buNone/>
+            </a:pPr>
+            <a:r>
+              <a:rPr lang="en-US" sz="1800" dirty="0">
+                <a:solidFill>
+                  <a:srgbClr val="8C8578"/>
+                </a:solidFill>
+                <a:latin typeface="Courier New" pitchFamily="34" charset="0"/>
+                <a:ea typeface="Courier New" pitchFamily="34" charset="-122"/>
+                <a:cs typeface="Courier New" pitchFamily="34" charset="-120"/>
+              </a:rPr>
+              <a:t>                 xhigh: max thinking — save it for the hard bugs</a:t>
             </a:r>
             <a:endParaRPr lang="en-US" sz="1800" dirty="0"/>
           </a:p>

</xml_diff>